<commit_message>
Add small knife cut positions to calibration GUI and update configurations
</commit_message>
<xml_diff>
--- a/Presentation/POC/POC_presentation_content.pptx
+++ b/Presentation/POC/POC_presentation_content.pptx
@@ -335,7 +335,7 @@
           <a:p>
             <a:fld id="{F77D4E7F-3A56-4AAA-AA74-4AAA8ACF2A0D}" type="datetimeFigureOut">
               <a:rPr lang="en-US" smtClean="0"/>
-              <a:t>6/24/2026</a:t>
+              <a:t>8/24/2026</a:t>
             </a:fld>
             <a:endParaRPr lang="en-US"/>
           </a:p>
@@ -533,7 +533,7 @@
           <a:p>
             <a:fld id="{F77D4E7F-3A56-4AAA-AA74-4AAA8ACF2A0D}" type="datetimeFigureOut">
               <a:rPr lang="en-US" smtClean="0"/>
-              <a:t>6/24/2026</a:t>
+              <a:t>8/24/2026</a:t>
             </a:fld>
             <a:endParaRPr lang="en-US"/>
           </a:p>
@@ -741,7 +741,7 @@
           <a:p>
             <a:fld id="{F77D4E7F-3A56-4AAA-AA74-4AAA8ACF2A0D}" type="datetimeFigureOut">
               <a:rPr lang="en-US" smtClean="0"/>
-              <a:t>6/24/2026</a:t>
+              <a:t>8/24/2026</a:t>
             </a:fld>
             <a:endParaRPr lang="en-US"/>
           </a:p>
@@ -939,7 +939,7 @@
           <a:p>
             <a:fld id="{F77D4E7F-3A56-4AAA-AA74-4AAA8ACF2A0D}" type="datetimeFigureOut">
               <a:rPr lang="en-US" smtClean="0"/>
-              <a:t>6/24/2026</a:t>
+              <a:t>8/24/2026</a:t>
             </a:fld>
             <a:endParaRPr lang="en-US"/>
           </a:p>
@@ -1214,7 +1214,7 @@
           <a:p>
             <a:fld id="{F77D4E7F-3A56-4AAA-AA74-4AAA8ACF2A0D}" type="datetimeFigureOut">
               <a:rPr lang="en-US" smtClean="0"/>
-              <a:t>6/24/2026</a:t>
+              <a:t>8/24/2026</a:t>
             </a:fld>
             <a:endParaRPr lang="en-US"/>
           </a:p>
@@ -1479,7 +1479,7 @@
           <a:p>
             <a:fld id="{F77D4E7F-3A56-4AAA-AA74-4AAA8ACF2A0D}" type="datetimeFigureOut">
               <a:rPr lang="en-US" smtClean="0"/>
-              <a:t>6/24/2026</a:t>
+              <a:t>8/24/2026</a:t>
             </a:fld>
             <a:endParaRPr lang="en-US"/>
           </a:p>
@@ -1891,7 +1891,7 @@
           <a:p>
             <a:fld id="{F77D4E7F-3A56-4AAA-AA74-4AAA8ACF2A0D}" type="datetimeFigureOut">
               <a:rPr lang="en-US" smtClean="0"/>
-              <a:t>6/24/2026</a:t>
+              <a:t>8/24/2026</a:t>
             </a:fld>
             <a:endParaRPr lang="en-US"/>
           </a:p>
@@ -2032,7 +2032,7 @@
           <a:p>
             <a:fld id="{F77D4E7F-3A56-4AAA-AA74-4AAA8ACF2A0D}" type="datetimeFigureOut">
               <a:rPr lang="en-US" smtClean="0"/>
-              <a:t>6/24/2026</a:t>
+              <a:t>8/24/2026</a:t>
             </a:fld>
             <a:endParaRPr lang="en-US"/>
           </a:p>
@@ -2145,7 +2145,7 @@
           <a:p>
             <a:fld id="{F77D4E7F-3A56-4AAA-AA74-4AAA8ACF2A0D}" type="datetimeFigureOut">
               <a:rPr lang="en-US" smtClean="0"/>
-              <a:t>6/24/2026</a:t>
+              <a:t>8/24/2026</a:t>
             </a:fld>
             <a:endParaRPr lang="en-US"/>
           </a:p>
@@ -2456,7 +2456,7 @@
           <a:p>
             <a:fld id="{F77D4E7F-3A56-4AAA-AA74-4AAA8ACF2A0D}" type="datetimeFigureOut">
               <a:rPr lang="en-US" smtClean="0"/>
-              <a:t>6/24/2026</a:t>
+              <a:t>8/24/2026</a:t>
             </a:fld>
             <a:endParaRPr lang="en-US"/>
           </a:p>
@@ -2744,7 +2744,7 @@
           <a:p>
             <a:fld id="{F77D4E7F-3A56-4AAA-AA74-4AAA8ACF2A0D}" type="datetimeFigureOut">
               <a:rPr lang="en-US" smtClean="0"/>
-              <a:t>6/24/2026</a:t>
+              <a:t>8/24/2026</a:t>
             </a:fld>
             <a:endParaRPr lang="en-US"/>
           </a:p>
@@ -2985,7 +2985,7 @@
           <a:p>
             <a:fld id="{F77D4E7F-3A56-4AAA-AA74-4AAA8ACF2A0D}" type="datetimeFigureOut">
               <a:rPr lang="en-US" smtClean="0"/>
-              <a:t>6/24/2026</a:t>
+              <a:t>8/24/2026</a:t>
             </a:fld>
             <a:endParaRPr lang="en-US"/>
           </a:p>

</xml_diff>